<commit_message>
Got the old working code back
</commit_message>
<xml_diff>
--- a/Documents for the project/Presentation.pptx
+++ b/Documents for the project/Presentation.pptx
@@ -9,18 +9,17 @@
     <p:sldId id="257" r:id="rId3"/>
     <p:sldId id="258" r:id="rId4"/>
     <p:sldId id="259" r:id="rId5"/>
-    <p:sldId id="260" r:id="rId6"/>
-    <p:sldId id="261" r:id="rId7"/>
-    <p:sldId id="262" r:id="rId8"/>
-    <p:sldId id="263" r:id="rId9"/>
+    <p:sldId id="272" r:id="rId6"/>
+    <p:sldId id="260" r:id="rId7"/>
+    <p:sldId id="273" r:id="rId8"/>
+    <p:sldId id="262" r:id="rId9"/>
     <p:sldId id="264" r:id="rId10"/>
     <p:sldId id="265" r:id="rId11"/>
-    <p:sldId id="266" r:id="rId12"/>
-    <p:sldId id="267" r:id="rId13"/>
-    <p:sldId id="268" r:id="rId14"/>
-    <p:sldId id="269" r:id="rId15"/>
-    <p:sldId id="270" r:id="rId16"/>
-    <p:sldId id="271" r:id="rId17"/>
+    <p:sldId id="267" r:id="rId12"/>
+    <p:sldId id="268" r:id="rId13"/>
+    <p:sldId id="269" r:id="rId14"/>
+    <p:sldId id="270" r:id="rId15"/>
+    <p:sldId id="271" r:id="rId16"/>
   </p:sldIdLst>
   <p:sldSz cx="12192000" cy="6858000"/>
   <p:notesSz cx="6858000" cy="9144000"/>
@@ -119,6 +118,11 @@
       </a:defRPr>
     </a:lvl9pPr>
   </p:defaultTextStyle>
+  <p:extLst>
+    <p:ext uri="{EFAFB233-063F-42B5-8137-9DF3F51BA10A}">
+      <p15:sldGuideLst xmlns:p15="http://schemas.microsoft.com/office/powerpoint/2012/main"/>
+    </p:ext>
+  </p:extLst>
 </p:presentation>
 </file>
 
@@ -178,6 +182,13 @@
             <a:schemeClr val="lt1"/>
           </a:fontRef>
         </p:style>
+        <p:txBody>
+          <a:bodyPr/>
+          <a:lstStyle/>
+          <a:p>
+            <a:endParaRPr lang="en-GB"/>
+          </a:p>
+        </p:txBody>
       </p:sp>
       <p:sp>
         <p:nvSpPr>
@@ -216,6 +227,13 @@
             <a:schemeClr val="lt1"/>
           </a:fontRef>
         </p:style>
+        <p:txBody>
+          <a:bodyPr/>
+          <a:lstStyle/>
+          <a:p>
+            <a:endParaRPr lang="en-GB"/>
+          </a:p>
+        </p:txBody>
       </p:sp>
       <p:sp>
         <p:nvSpPr>
@@ -339,7 +357,7 @@
           <a:p>
             <a:fld id="{6444479B-705B-4489-957E-7E8A228BDFA0}" type="datetime1">
               <a:rPr lang="en-US" smtClean="0"/>
-              <a:t>1/26/2026</a:t>
+              <a:t>2/5/2026</a:t>
             </a:fld>
             <a:endParaRPr lang="en-US"/>
           </a:p>
@@ -674,7 +692,7 @@
           <a:p>
             <a:fld id="{C07B66AD-7C08-490A-ADA4-B47E10FB2407}" type="datetime1">
               <a:rPr lang="en-US" smtClean="0"/>
-              <a:t>1/26/2026</a:t>
+              <a:t>2/5/2026</a:t>
             </a:fld>
             <a:endParaRPr lang="en-US"/>
           </a:p>
@@ -977,7 +995,7 @@
           <a:p>
             <a:fld id="{05B95027-4255-49E7-9841-CD21BCC99996}" type="datetime1">
               <a:rPr lang="en-US" smtClean="0"/>
-              <a:t>1/26/2026</a:t>
+              <a:t>2/5/2026</a:t>
             </a:fld>
             <a:endParaRPr lang="en-US"/>
           </a:p>
@@ -1225,7 +1243,7 @@
           <a:p>
             <a:fld id="{9F89F774-3FA6-43B8-9241-99959C8FD463}" type="datetime1">
               <a:rPr lang="en-US" smtClean="0"/>
-              <a:t>1/26/2026</a:t>
+              <a:t>2/5/2026</a:t>
             </a:fld>
             <a:endParaRPr lang="en-US"/>
           </a:p>
@@ -1633,7 +1651,7 @@
           <a:p>
             <a:fld id="{F9504452-5DCC-4FE2-A5C9-8A5EF6714D65}" type="datetime1">
               <a:rPr lang="en-US" smtClean="0"/>
-              <a:t>1/26/2026</a:t>
+              <a:t>2/5/2026</a:t>
             </a:fld>
             <a:endParaRPr lang="en-US"/>
           </a:p>
@@ -1948,7 +1966,7 @@
           <a:p>
             <a:fld id="{E579ABC2-0180-4F3A-A895-A85BC724D472}" type="datetime1">
               <a:rPr lang="en-US" smtClean="0"/>
-              <a:t>1/26/2026</a:t>
+              <a:t>2/5/2026</a:t>
             </a:fld>
             <a:endParaRPr lang="en-US"/>
           </a:p>
@@ -2493,7 +2511,7 @@
           <a:p>
             <a:fld id="{6AEEA9BA-4E8F-439E-BEA4-91FBA01E3F5F}" type="datetime1">
               <a:rPr lang="en-US" smtClean="0"/>
-              <a:t>1/26/2026</a:t>
+              <a:t>2/5/2026</a:t>
             </a:fld>
             <a:endParaRPr lang="en-US"/>
           </a:p>
@@ -2689,7 +2707,7 @@
           <a:p>
             <a:fld id="{BE15BF18-0007-481C-AA29-413124BC3EE7}" type="datetime1">
               <a:rPr lang="en-US" smtClean="0"/>
-              <a:t>1/26/2026</a:t>
+              <a:t>2/5/2026</a:t>
             </a:fld>
             <a:endParaRPr lang="en-US"/>
           </a:p>
@@ -2903,7 +2921,7 @@
           <a:p>
             <a:fld id="{09BE9870-3748-43AD-B547-02A075CB4A1D}" type="datetime1">
               <a:rPr lang="en-US" smtClean="0"/>
-              <a:t>1/26/2026</a:t>
+              <a:t>2/5/2026</a:t>
             </a:fld>
             <a:endParaRPr lang="en-US"/>
           </a:p>
@@ -3273,7 +3291,7 @@
           <a:p>
             <a:fld id="{558E7897-33C5-4F1A-9307-D068E37F3DC7}" type="datetime1">
               <a:rPr lang="en-US" smtClean="0"/>
-              <a:t>1/26/2026</a:t>
+              <a:t>2/5/2026</a:t>
             </a:fld>
             <a:endParaRPr lang="en-US"/>
           </a:p>
@@ -3677,7 +3695,7 @@
           <a:p>
             <a:fld id="{82E171BA-CC09-47C8-A6DF-F5C5CB59CEEC}" type="datetime1">
               <a:rPr lang="en-US" smtClean="0"/>
-              <a:t>1/26/2026</a:t>
+              <a:t>2/5/2026</a:t>
             </a:fld>
             <a:endParaRPr lang="en-US"/>
           </a:p>
@@ -3857,6 +3875,13 @@
             <a:schemeClr val="lt1"/>
           </a:fontRef>
         </p:style>
+        <p:txBody>
+          <a:bodyPr/>
+          <a:lstStyle/>
+          <a:p>
+            <a:endParaRPr lang="en-GB"/>
+          </a:p>
+        </p:txBody>
       </p:sp>
       <p:sp>
         <p:nvSpPr>
@@ -3989,7 +4014,7 @@
           <a:p>
             <a:fld id="{7DA38F49-B3E2-4BF0-BEC7-C30D34ABBB8D}" type="datetime1">
               <a:rPr lang="en-US" smtClean="0"/>
-              <a:t>1/26/2026</a:t>
+              <a:t>2/5/2026</a:t>
             </a:fld>
             <a:endParaRPr lang="en-US"/>
           </a:p>
@@ -4110,6 +4135,13 @@
             <a:schemeClr val="lt1"/>
           </a:fontRef>
         </p:style>
+        <p:txBody>
+          <a:bodyPr/>
+          <a:lstStyle/>
+          <a:p>
+            <a:endParaRPr lang="en-GB"/>
+          </a:p>
+        </p:txBody>
       </p:sp>
     </p:spTree>
     <p:extLst>
@@ -4802,14 +4834,19 @@
             <p:ph type="title"/>
           </p:nvPr>
         </p:nvSpPr>
-        <p:spPr/>
+        <p:spPr>
+          <a:xfrm>
+            <a:off x="2611809" y="808056"/>
+            <a:ext cx="3290228" cy="1077229"/>
+          </a:xfrm>
+        </p:spPr>
         <p:txBody>
           <a:bodyPr/>
           <a:lstStyle/>
           <a:p>
             <a:r>
               <a:rPr lang="en-GB" dirty="0"/>
-              <a:t>Videos of testing(Non technical report)</a:t>
+              <a:t>Video of Testing</a:t>
             </a:r>
           </a:p>
         </p:txBody>
@@ -4874,7 +4911,7 @@
           <p:cNvPr id="2" name="Title 1">
             <a:extLst>
               <a:ext uri="{FF2B5EF4-FFF2-40B4-BE49-F238E27FC236}">
-                <a16:creationId xmlns:a16="http://schemas.microsoft.com/office/drawing/2014/main" id="{B37E5A75-80F4-1DE8-F757-C350CABDDC9A}"/>
+                <a16:creationId xmlns:a16="http://schemas.microsoft.com/office/drawing/2014/main" id="{7F8B2D19-8C3D-CAE4-E0EC-DF418910A98F}"/>
               </a:ext>
             </a:extLst>
           </p:cNvPr>
@@ -4885,14 +4922,19 @@
             <p:ph type="title"/>
           </p:nvPr>
         </p:nvSpPr>
-        <p:spPr/>
+        <p:spPr>
+          <a:xfrm>
+            <a:off x="2611809" y="808056"/>
+            <a:ext cx="5058068" cy="1077229"/>
+          </a:xfrm>
+        </p:spPr>
         <p:txBody>
           <a:bodyPr/>
           <a:lstStyle/>
           <a:p>
             <a:r>
               <a:rPr lang="en-GB" dirty="0"/>
-              <a:t>Videos of testing(Technical report)</a:t>
+              <a:t>Things I Have Completed</a:t>
             </a:r>
           </a:p>
         </p:txBody>
@@ -4902,7 +4944,7 @@
           <p:cNvPr id="3" name="Content Placeholder 2">
             <a:extLst>
               <a:ext uri="{FF2B5EF4-FFF2-40B4-BE49-F238E27FC236}">
-                <a16:creationId xmlns:a16="http://schemas.microsoft.com/office/drawing/2014/main" id="{38D4E181-E0C5-8DEF-E917-9AA7A93D93B4}"/>
+                <a16:creationId xmlns:a16="http://schemas.microsoft.com/office/drawing/2014/main" id="{92668A11-8E78-A3C5-4499-DD461E81A343}"/>
               </a:ext>
             </a:extLst>
           </p:cNvPr>
@@ -4918,14 +4960,35 @@
           <a:bodyPr/>
           <a:lstStyle/>
           <a:p>
-            <a:endParaRPr lang="en-GB"/>
+            <a:r>
+              <a:rPr lang="en-GB" dirty="0"/>
+              <a:t>Coded all the checks I want to perform on the URL</a:t>
+            </a:r>
+          </a:p>
+          <a:p>
+            <a:r>
+              <a:rPr lang="en-GB" dirty="0"/>
+              <a:t>Gave the AI model the ability to judge the results on the vector and make a decision</a:t>
+            </a:r>
+          </a:p>
+          <a:p>
+            <a:r>
+              <a:rPr lang="en-GB" dirty="0"/>
+              <a:t>Outputs the verdict made by the AI model alongside a confidence assessment</a:t>
+            </a:r>
+          </a:p>
+          <a:p>
+            <a:r>
+              <a:rPr lang="en-GB" dirty="0"/>
+              <a:t>Outputs a small paragraph explaining why the assessment was made</a:t>
+            </a:r>
           </a:p>
         </p:txBody>
       </p:sp>
     </p:spTree>
     <p:extLst>
       <p:ext uri="{BB962C8B-B14F-4D97-AF65-F5344CB8AC3E}">
-        <p14:creationId xmlns:p14="http://schemas.microsoft.com/office/powerpoint/2010/main" val="102967284"/>
+        <p14:creationId xmlns:p14="http://schemas.microsoft.com/office/powerpoint/2010/main" val="3914912943"/>
       </p:ext>
     </p:extLst>
   </p:cSld>
@@ -4957,7 +5020,7 @@
           <p:cNvPr id="2" name="Title 1">
             <a:extLst>
               <a:ext uri="{FF2B5EF4-FFF2-40B4-BE49-F238E27FC236}">
-                <a16:creationId xmlns:a16="http://schemas.microsoft.com/office/drawing/2014/main" id="{7F8B2D19-8C3D-CAE4-E0EC-DF418910A98F}"/>
+                <a16:creationId xmlns:a16="http://schemas.microsoft.com/office/drawing/2014/main" id="{C0F69B51-1C71-9657-F6F2-C778D6F2F417}"/>
               </a:ext>
             </a:extLst>
           </p:cNvPr>
@@ -4970,8 +5033,8 @@
         </p:nvSpPr>
         <p:spPr>
           <a:xfrm>
-            <a:off x="2611809" y="808056"/>
-            <a:ext cx="5058068" cy="1077229"/>
+            <a:off x="2611808" y="808056"/>
+            <a:ext cx="1566723" cy="1077229"/>
           </a:xfrm>
         </p:spPr>
         <p:txBody>
@@ -4980,7 +5043,7 @@
           <a:p>
             <a:r>
               <a:rPr lang="en-GB" dirty="0"/>
-              <a:t>Things I Have Completed</a:t>
+              <a:t>Testing</a:t>
             </a:r>
           </a:p>
         </p:txBody>
@@ -4990,7 +5053,7 @@
           <p:cNvPr id="3" name="Content Placeholder 2">
             <a:extLst>
               <a:ext uri="{FF2B5EF4-FFF2-40B4-BE49-F238E27FC236}">
-                <a16:creationId xmlns:a16="http://schemas.microsoft.com/office/drawing/2014/main" id="{92668A11-8E78-A3C5-4499-DD461E81A343}"/>
+                <a16:creationId xmlns:a16="http://schemas.microsoft.com/office/drawing/2014/main" id="{335DD3D7-8555-AB94-8159-50F96D8E0ED9}"/>
               </a:ext>
             </a:extLst>
           </p:cNvPr>
@@ -5006,14 +5069,29 @@
           <a:bodyPr/>
           <a:lstStyle/>
           <a:p>
-            <a:endParaRPr lang="en-GB" dirty="0"/>
+            <a:r>
+              <a:rPr lang="en-GB" dirty="0"/>
+              <a:t>Creating a test plan to effectively test all the key functions of my project and ensure they work as planned.</a:t>
+            </a:r>
+          </a:p>
+          <a:p>
+            <a:r>
+              <a:rPr lang="en-GB" dirty="0"/>
+              <a:t>I am going to conduct participant testing to see the effectiveness of the systems feedback and whether or not users are confident in the systems ability.</a:t>
+            </a:r>
+          </a:p>
+          <a:p>
+            <a:r>
+              <a:rPr lang="en-GB" dirty="0"/>
+              <a:t>I have done research into websites I can gather URLs to test the Ais ability in correctly judging the nature of the URLs being inputted.</a:t>
+            </a:r>
           </a:p>
         </p:txBody>
       </p:sp>
     </p:spTree>
     <p:extLst>
       <p:ext uri="{BB962C8B-B14F-4D97-AF65-F5344CB8AC3E}">
-        <p14:creationId xmlns:p14="http://schemas.microsoft.com/office/powerpoint/2010/main" val="3914912943"/>
+        <p14:creationId xmlns:p14="http://schemas.microsoft.com/office/powerpoint/2010/main" val="2907730919"/>
       </p:ext>
     </p:extLst>
   </p:cSld>
@@ -5045,7 +5123,7 @@
           <p:cNvPr id="2" name="Title 1">
             <a:extLst>
               <a:ext uri="{FF2B5EF4-FFF2-40B4-BE49-F238E27FC236}">
-                <a16:creationId xmlns:a16="http://schemas.microsoft.com/office/drawing/2014/main" id="{C0F69B51-1C71-9657-F6F2-C778D6F2F417}"/>
+                <a16:creationId xmlns:a16="http://schemas.microsoft.com/office/drawing/2014/main" id="{B80A6045-5949-1D36-EF72-EF499F7C662B}"/>
               </a:ext>
             </a:extLst>
           </p:cNvPr>
@@ -5059,7 +5137,7 @@
         <p:spPr>
           <a:xfrm>
             <a:off x="2611808" y="808056"/>
-            <a:ext cx="1566723" cy="1077229"/>
+            <a:ext cx="6183057" cy="1077229"/>
           </a:xfrm>
         </p:spPr>
         <p:txBody>
@@ -5068,7 +5146,7 @@
           <a:p>
             <a:r>
               <a:rPr lang="en-GB" dirty="0"/>
-              <a:t>Testing</a:t>
+              <a:t>What I’m Currently Working On</a:t>
             </a:r>
           </a:p>
         </p:txBody>
@@ -5078,7 +5156,7 @@
           <p:cNvPr id="3" name="Content Placeholder 2">
             <a:extLst>
               <a:ext uri="{FF2B5EF4-FFF2-40B4-BE49-F238E27FC236}">
-                <a16:creationId xmlns:a16="http://schemas.microsoft.com/office/drawing/2014/main" id="{335DD3D7-8555-AB94-8159-50F96D8E0ED9}"/>
+                <a16:creationId xmlns:a16="http://schemas.microsoft.com/office/drawing/2014/main" id="{C8A8993E-E25F-8924-30D9-8FAF062108E7}"/>
               </a:ext>
             </a:extLst>
           </p:cNvPr>
@@ -5094,14 +5172,23 @@
           <a:bodyPr/>
           <a:lstStyle/>
           <a:p>
-            <a:endParaRPr lang="en-GB"/>
+            <a:r>
+              <a:rPr lang="en-GB" dirty="0"/>
+              <a:t>I’m currently researching about adding datasets containing roughly 50,000 URLs to replace my hardcoded phishing and legitimate URLs.</a:t>
+            </a:r>
+          </a:p>
+          <a:p>
+            <a:r>
+              <a:rPr lang="en-GB" dirty="0"/>
+              <a:t>Researching values to display on a report technical users can look at after analysis of the URL is complete.</a:t>
+            </a:r>
           </a:p>
         </p:txBody>
       </p:sp>
     </p:spTree>
     <p:extLst>
       <p:ext uri="{BB962C8B-B14F-4D97-AF65-F5344CB8AC3E}">
-        <p14:creationId xmlns:p14="http://schemas.microsoft.com/office/powerpoint/2010/main" val="2907730919"/>
+        <p14:creationId xmlns:p14="http://schemas.microsoft.com/office/powerpoint/2010/main" val="2330332146"/>
       </p:ext>
     </p:extLst>
   </p:cSld>
@@ -5133,7 +5220,7 @@
           <p:cNvPr id="2" name="Title 1">
             <a:extLst>
               <a:ext uri="{FF2B5EF4-FFF2-40B4-BE49-F238E27FC236}">
-                <a16:creationId xmlns:a16="http://schemas.microsoft.com/office/drawing/2014/main" id="{B80A6045-5949-1D36-EF72-EF499F7C662B}"/>
+                <a16:creationId xmlns:a16="http://schemas.microsoft.com/office/drawing/2014/main" id="{433CEE8C-9A04-4120-9BD7-88A6DD5B907D}"/>
               </a:ext>
             </a:extLst>
           </p:cNvPr>
@@ -5147,7 +5234,7 @@
         <p:spPr>
           <a:xfrm>
             <a:off x="2611808" y="808056"/>
-            <a:ext cx="6183057" cy="1077229"/>
+            <a:ext cx="6138723" cy="1077229"/>
           </a:xfrm>
         </p:spPr>
         <p:txBody>
@@ -5156,7 +5243,7 @@
           <a:p>
             <a:r>
               <a:rPr lang="en-GB" dirty="0"/>
-              <a:t>What I’m Currently Working On</a:t>
+              <a:t>Things I’m Hoping To Work On</a:t>
             </a:r>
           </a:p>
         </p:txBody>
@@ -5166,7 +5253,7 @@
           <p:cNvPr id="3" name="Content Placeholder 2">
             <a:extLst>
               <a:ext uri="{FF2B5EF4-FFF2-40B4-BE49-F238E27FC236}">
-                <a16:creationId xmlns:a16="http://schemas.microsoft.com/office/drawing/2014/main" id="{C8A8993E-E25F-8924-30D9-8FAF062108E7}"/>
+                <a16:creationId xmlns:a16="http://schemas.microsoft.com/office/drawing/2014/main" id="{B408CCC1-0C99-4580-D0A4-0E255A130109}"/>
               </a:ext>
             </a:extLst>
           </p:cNvPr>
@@ -5182,14 +5269,35 @@
           <a:bodyPr/>
           <a:lstStyle/>
           <a:p>
-            <a:endParaRPr lang="en-GB"/>
+            <a:r>
+              <a:rPr lang="en-GB" dirty="0"/>
+              <a:t>Building a mini plugin version of the website</a:t>
+            </a:r>
+          </a:p>
+          <a:p>
+            <a:r>
+              <a:rPr lang="en-US" dirty="0"/>
+              <a:t>Introducing a more advanced check that significantly strengthens the system, such as form action–domain mismatch detection.</a:t>
+            </a:r>
+          </a:p>
+          <a:p>
+            <a:r>
+              <a:rPr lang="en-GB" dirty="0"/>
+              <a:t>Designing a small feature that outputs the specific URL checks that the AI model found the URL didn’t pass.</a:t>
+            </a:r>
+          </a:p>
+          <a:p>
+            <a:endParaRPr lang="en-US" dirty="0"/>
+          </a:p>
+          <a:p>
+            <a:endParaRPr lang="en-GB" dirty="0"/>
           </a:p>
         </p:txBody>
       </p:sp>
     </p:spTree>
     <p:extLst>
       <p:ext uri="{BB962C8B-B14F-4D97-AF65-F5344CB8AC3E}">
-        <p14:creationId xmlns:p14="http://schemas.microsoft.com/office/powerpoint/2010/main" val="2330332146"/>
+        <p14:creationId xmlns:p14="http://schemas.microsoft.com/office/powerpoint/2010/main" val="1966749248"/>
       </p:ext>
     </p:extLst>
   </p:cSld>
@@ -5221,94 +5329,6 @@
           <p:cNvPr id="2" name="Title 1">
             <a:extLst>
               <a:ext uri="{FF2B5EF4-FFF2-40B4-BE49-F238E27FC236}">
-                <a16:creationId xmlns:a16="http://schemas.microsoft.com/office/drawing/2014/main" id="{433CEE8C-9A04-4120-9BD7-88A6DD5B907D}"/>
-              </a:ext>
-            </a:extLst>
-          </p:cNvPr>
-          <p:cNvSpPr>
-            <a:spLocks noGrp="1"/>
-          </p:cNvSpPr>
-          <p:nvPr>
-            <p:ph type="title"/>
-          </p:nvPr>
-        </p:nvSpPr>
-        <p:spPr>
-          <a:xfrm>
-            <a:off x="2611808" y="808056"/>
-            <a:ext cx="6138723" cy="1077229"/>
-          </a:xfrm>
-        </p:spPr>
-        <p:txBody>
-          <a:bodyPr/>
-          <a:lstStyle/>
-          <a:p>
-            <a:r>
-              <a:rPr lang="en-GB" dirty="0"/>
-              <a:t>Things I’m Hoping To Work On</a:t>
-            </a:r>
-          </a:p>
-        </p:txBody>
-      </p:sp>
-      <p:sp>
-        <p:nvSpPr>
-          <p:cNvPr id="3" name="Content Placeholder 2">
-            <a:extLst>
-              <a:ext uri="{FF2B5EF4-FFF2-40B4-BE49-F238E27FC236}">
-                <a16:creationId xmlns:a16="http://schemas.microsoft.com/office/drawing/2014/main" id="{B408CCC1-0C99-4580-D0A4-0E255A130109}"/>
-              </a:ext>
-            </a:extLst>
-          </p:cNvPr>
-          <p:cNvSpPr>
-            <a:spLocks noGrp="1"/>
-          </p:cNvSpPr>
-          <p:nvPr>
-            <p:ph idx="1"/>
-          </p:nvPr>
-        </p:nvSpPr>
-        <p:spPr/>
-        <p:txBody>
-          <a:bodyPr/>
-          <a:lstStyle/>
-          <a:p>
-            <a:endParaRPr lang="en-GB"/>
-          </a:p>
-        </p:txBody>
-      </p:sp>
-    </p:spTree>
-    <p:extLst>
-      <p:ext uri="{BB962C8B-B14F-4D97-AF65-F5344CB8AC3E}">
-        <p14:creationId xmlns:p14="http://schemas.microsoft.com/office/powerpoint/2010/main" val="1966749248"/>
-      </p:ext>
-    </p:extLst>
-  </p:cSld>
-  <p:clrMapOvr>
-    <a:masterClrMapping/>
-  </p:clrMapOvr>
-</p:sld>
-</file>
-
-<file path=ppt/slides/slide16.xml><?xml version="1.0" encoding="utf-8"?>
-<p:sld xmlns:a="http://schemas.openxmlformats.org/drawingml/2006/main" xmlns:r="http://schemas.openxmlformats.org/officeDocument/2006/relationships" xmlns:p="http://schemas.openxmlformats.org/presentationml/2006/main">
-  <p:cSld>
-    <p:spTree>
-      <p:nvGrpSpPr>
-        <p:cNvPr id="1" name=""/>
-        <p:cNvGrpSpPr/>
-        <p:nvPr/>
-      </p:nvGrpSpPr>
-      <p:grpSpPr>
-        <a:xfrm>
-          <a:off x="0" y="0"/>
-          <a:ext cx="0" cy="0"/>
-          <a:chOff x="0" y="0"/>
-          <a:chExt cx="0" cy="0"/>
-        </a:xfrm>
-      </p:grpSpPr>
-      <p:sp>
-        <p:nvSpPr>
-          <p:cNvPr id="2" name="Title 1">
-            <a:extLst>
-              <a:ext uri="{FF2B5EF4-FFF2-40B4-BE49-F238E27FC236}">
                 <a16:creationId xmlns:a16="http://schemas.microsoft.com/office/drawing/2014/main" id="{38910D02-2FCC-6DB1-DBF7-68BD9815ADED}"/>
               </a:ext>
             </a:extLst>
@@ -5355,10 +5375,42 @@
         </p:nvSpPr>
         <p:spPr/>
         <p:txBody>
-          <a:bodyPr/>
-          <a:lstStyle/>
-          <a:p>
-            <a:endParaRPr lang="en-GB"/>
+          <a:bodyPr>
+            <a:normAutofit fontScale="92500" lnSpcReduction="20000"/>
+          </a:bodyPr>
+          <a:lstStyle/>
+          <a:p>
+            <a:r>
+              <a:rPr lang="en-GB" dirty="0"/>
+              <a:t>Roughly 5 participants</a:t>
+            </a:r>
+          </a:p>
+          <a:p>
+            <a:r>
+              <a:rPr lang="en-GB" dirty="0"/>
+              <a:t>Consent forms will be signed to start the evaluation</a:t>
+            </a:r>
+          </a:p>
+          <a:p>
+            <a:r>
+              <a:rPr lang="en-GB" dirty="0"/>
+              <a:t>A timer will be started as participants will have up to 5 minutes to navigate the website and gain feedback on the URL they pasted</a:t>
+            </a:r>
+          </a:p>
+          <a:p>
+            <a:r>
+              <a:rPr lang="en-GB" dirty="0"/>
+              <a:t>Once the participant is satisfied with exploring the system or the timer has ended, a questionnaire will be handed to them</a:t>
+            </a:r>
+          </a:p>
+          <a:p>
+            <a:r>
+              <a:rPr lang="en-GB" dirty="0"/>
+              <a:t>Their responses to the questionnaire will be used to see if the participant understood feedback, if they felt the website was lacking any information/features and if they are confident in the systems ability.</a:t>
+            </a:r>
+          </a:p>
+          <a:p>
+            <a:endParaRPr lang="en-GB" dirty="0"/>
           </a:p>
         </p:txBody>
       </p:sp>
@@ -5829,7 +5881,7 @@
                   <a:schemeClr val="tx2"/>
                 </a:solidFill>
               </a:rPr>
-              <a:t>Insert URL’s of legitimate and phishing natures to see if the AI model is trained enough to provide correct and effective feedback</a:t>
+              <a:t>Insert URL’s of legitimate and phishing natures to see if an AI model is capable of providing correct and effective feedback</a:t>
             </a:r>
           </a:p>
         </p:txBody>
@@ -5975,21 +6027,39 @@
             <p:ph idx="1"/>
           </p:nvPr>
         </p:nvSpPr>
-        <p:spPr/>
-        <p:txBody>
-          <a:bodyPr/>
+        <p:spPr>
+          <a:xfrm>
+            <a:off x="2773599" y="2052116"/>
+            <a:ext cx="7796540" cy="2874560"/>
+          </a:xfrm>
+        </p:spPr>
+        <p:txBody>
+          <a:bodyPr>
+            <a:normAutofit lnSpcReduction="10000"/>
+          </a:bodyPr>
           <a:lstStyle/>
           <a:p>
             <a:r>
               <a:rPr lang="en-GB" dirty="0"/>
-              <a:t>Businesses and charities are always under constant threats from phishing and succumbing to their deception</a:t>
+              <a:t>Protecting businesses and charities from phishing and succumbing to its deception as they are the biggest targets of such a threat.</a:t>
             </a:r>
           </a:p>
           <a:p>
             <a:r>
               <a:rPr lang="en-GB" dirty="0"/>
-              <a:t>Everyday users are also susceptible to being deceived maybe due to a lack of knowledge of the threat and how to avoid it</a:t>
-            </a:r>
+              <a:t>Everyday users are also susceptible to being deceived maybe due to a lack of knowledge of the threat and how to avoid it.</a:t>
+            </a:r>
+          </a:p>
+          <a:p>
+            <a:r>
+              <a:rPr lang="en-GB" dirty="0"/>
+              <a:t>Introducing a smarter system that can keep up with </a:t>
+            </a:r>
+            <a:r>
+              <a:rPr lang="en-US" dirty="0"/>
+              <a:t> AI-driven, highly targeted, and multi-channel attacks</a:t>
+            </a:r>
+            <a:endParaRPr lang="en-GB" dirty="0"/>
           </a:p>
         </p:txBody>
       </p:sp>
@@ -6077,7 +6147,22 @@
           <a:bodyPr/>
           <a:lstStyle/>
           <a:p>
-            <a:endParaRPr lang="en-GB"/>
+            <a:r>
+              <a:rPr lang="en-GB" dirty="0"/>
+              <a:t>Conduct research into existing phishing detection systems and see what gaps are in their systems that AI can fill</a:t>
+            </a:r>
+          </a:p>
+          <a:p>
+            <a:r>
+              <a:rPr lang="en-GB" dirty="0"/>
+              <a:t>Fully implement an AI model that correctly and quickly identifies URL’s that are a threat to users</a:t>
+            </a:r>
+          </a:p>
+          <a:p>
+            <a:r>
+              <a:rPr lang="en-GB" dirty="0"/>
+              <a:t>Display a user friendly report of the systems analysis to the user to allow them to better understand the components and trends in a phishing URL</a:t>
+            </a:r>
           </a:p>
         </p:txBody>
       </p:sp>
@@ -6116,7 +6201,7 @@
           <p:cNvPr id="2" name="Title 1">
             <a:extLst>
               <a:ext uri="{FF2B5EF4-FFF2-40B4-BE49-F238E27FC236}">
-                <a16:creationId xmlns:a16="http://schemas.microsoft.com/office/drawing/2014/main" id="{08A88792-C78D-170B-2915-FBB69E4910C4}"/>
+                <a16:creationId xmlns:a16="http://schemas.microsoft.com/office/drawing/2014/main" id="{BE6FCB9B-EDBC-139F-FD67-B7E1668FE57C}"/>
               </a:ext>
             </a:extLst>
           </p:cNvPr>
@@ -6129,8 +6214,8 @@
         </p:nvSpPr>
         <p:spPr>
           <a:xfrm>
-            <a:off x="2611808" y="808056"/>
-            <a:ext cx="5544905" cy="1077229"/>
+            <a:off x="2611809" y="808056"/>
+            <a:ext cx="2226198" cy="1077229"/>
           </a:xfrm>
         </p:spPr>
         <p:txBody>
@@ -6139,7 +6224,7 @@
           <a:p>
             <a:r>
               <a:rPr lang="en-GB" dirty="0"/>
-              <a:t>Approach and Organisation</a:t>
+              <a:t>Objectives</a:t>
             </a:r>
           </a:p>
         </p:txBody>
@@ -6149,7 +6234,7 @@
           <p:cNvPr id="3" name="Content Placeholder 2">
             <a:extLst>
               <a:ext uri="{FF2B5EF4-FFF2-40B4-BE49-F238E27FC236}">
-                <a16:creationId xmlns:a16="http://schemas.microsoft.com/office/drawing/2014/main" id="{8FDF9499-B8AE-9307-0943-42D9627AE25B}"/>
+                <a16:creationId xmlns:a16="http://schemas.microsoft.com/office/drawing/2014/main" id="{4CA903D1-382A-7F9C-89DC-3FE4C2671C55}"/>
               </a:ext>
             </a:extLst>
           </p:cNvPr>
@@ -6165,14 +6250,29 @@
           <a:bodyPr/>
           <a:lstStyle/>
           <a:p>
-            <a:endParaRPr lang="en-GB"/>
+            <a:r>
+              <a:rPr lang="en-GB" dirty="0"/>
+              <a:t>Develop a testing table to effectively test all the features of my system and ensure they work correctly</a:t>
+            </a:r>
+          </a:p>
+          <a:p>
+            <a:r>
+              <a:rPr lang="en-GB" dirty="0"/>
+              <a:t>Conduct participant testing to observe the effectiveness of the systems feedback</a:t>
+            </a:r>
+          </a:p>
+          <a:p>
+            <a:r>
+              <a:rPr lang="en-GB" dirty="0"/>
+              <a:t>Complete the dissertation</a:t>
+            </a:r>
           </a:p>
         </p:txBody>
       </p:sp>
     </p:spTree>
     <p:extLst>
       <p:ext uri="{BB962C8B-B14F-4D97-AF65-F5344CB8AC3E}">
-        <p14:creationId xmlns:p14="http://schemas.microsoft.com/office/powerpoint/2010/main" val="1032098287"/>
+        <p14:creationId xmlns:p14="http://schemas.microsoft.com/office/powerpoint/2010/main" val="3094156842"/>
       </p:ext>
     </p:extLst>
   </p:cSld>
@@ -6204,7 +6304,7 @@
           <p:cNvPr id="2" name="Title 1">
             <a:extLst>
               <a:ext uri="{FF2B5EF4-FFF2-40B4-BE49-F238E27FC236}">
-                <a16:creationId xmlns:a16="http://schemas.microsoft.com/office/drawing/2014/main" id="{AA49821E-09A4-BA7C-6236-2EA0A010F345}"/>
+                <a16:creationId xmlns:a16="http://schemas.microsoft.com/office/drawing/2014/main" id="{08A88792-C78D-170B-2915-FBB69E4910C4}"/>
               </a:ext>
             </a:extLst>
           </p:cNvPr>
@@ -6217,8 +6317,8 @@
         </p:nvSpPr>
         <p:spPr>
           <a:xfrm>
-            <a:off x="2611809" y="808056"/>
-            <a:ext cx="1536122" cy="1077229"/>
+            <a:off x="2611808" y="808056"/>
+            <a:ext cx="5544905" cy="1077229"/>
           </a:xfrm>
         </p:spPr>
         <p:txBody>
@@ -6227,7 +6327,7 @@
           <a:p>
             <a:r>
               <a:rPr lang="en-GB" dirty="0"/>
-              <a:t>Design</a:t>
+              <a:t>Approach and Organisation</a:t>
             </a:r>
           </a:p>
         </p:txBody>
@@ -6237,7 +6337,7 @@
           <p:cNvPr id="3" name="Content Placeholder 2">
             <a:extLst>
               <a:ext uri="{FF2B5EF4-FFF2-40B4-BE49-F238E27FC236}">
-                <a16:creationId xmlns:a16="http://schemas.microsoft.com/office/drawing/2014/main" id="{191670EA-34EE-C049-B80F-355B897F398D}"/>
+                <a16:creationId xmlns:a16="http://schemas.microsoft.com/office/drawing/2014/main" id="{8FDF9499-B8AE-9307-0943-42D9627AE25B}"/>
               </a:ext>
             </a:extLst>
           </p:cNvPr>
@@ -6250,17 +6350,35 @@
         </p:nvSpPr>
         <p:spPr/>
         <p:txBody>
-          <a:bodyPr/>
-          <a:lstStyle/>
-          <a:p>
-            <a:endParaRPr lang="en-GB"/>
+          <a:bodyPr>
+            <a:normAutofit fontScale="92500" lnSpcReduction="10000"/>
+          </a:bodyPr>
+          <a:lstStyle/>
+          <a:p>
+            <a:r>
+              <a:rPr lang="en-US" dirty="0"/>
+              <a:t>I approached this project using a feature driven agile approach inspired by Feature-Driven Development. This encouraged me to clearly define and document the features I wanted to implement before writing code, which made the development process more structured and the implementation clearer.</a:t>
+            </a:r>
+          </a:p>
+          <a:p>
+            <a:r>
+              <a:rPr lang="en-US" dirty="0"/>
+              <a:t>Because organization was a key requirement of the project, working in a feature focused way helped me stay focused and progress systematically.</a:t>
+            </a:r>
+          </a:p>
+          <a:p>
+            <a:r>
+              <a:rPr lang="en-US" dirty="0"/>
+              <a:t>As the project was developed over most of the academic year, using a feature-driven methodology suited well with its long-term nature.</a:t>
+            </a:r>
+            <a:endParaRPr lang="en-GB" dirty="0"/>
           </a:p>
         </p:txBody>
       </p:sp>
     </p:spTree>
     <p:extLst>
       <p:ext uri="{BB962C8B-B14F-4D97-AF65-F5344CB8AC3E}">
-        <p14:creationId xmlns:p14="http://schemas.microsoft.com/office/powerpoint/2010/main" val="2249796300"/>
+        <p14:creationId xmlns:p14="http://schemas.microsoft.com/office/powerpoint/2010/main" val="1032098287"/>
       </p:ext>
     </p:extLst>
   </p:cSld>
@@ -6292,7 +6410,7 @@
           <p:cNvPr id="2" name="Title 1">
             <a:extLst>
               <a:ext uri="{FF2B5EF4-FFF2-40B4-BE49-F238E27FC236}">
-                <a16:creationId xmlns:a16="http://schemas.microsoft.com/office/drawing/2014/main" id="{4982E630-CCA6-6F6D-0EE0-9FFB35E1B0AC}"/>
+                <a16:creationId xmlns:a16="http://schemas.microsoft.com/office/drawing/2014/main" id="{6ADFBF0B-62DD-94C2-9EF3-8337925AE959}"/>
               </a:ext>
             </a:extLst>
           </p:cNvPr>
@@ -6305,8 +6423,8 @@
         </p:nvSpPr>
         <p:spPr>
           <a:xfrm>
-            <a:off x="2611808" y="808056"/>
-            <a:ext cx="4014279" cy="1077229"/>
+            <a:off x="2611809" y="808056"/>
+            <a:ext cx="5445996" cy="1077229"/>
           </a:xfrm>
         </p:spPr>
         <p:txBody>
@@ -6315,7 +6433,7 @@
           <a:p>
             <a:r>
               <a:rPr lang="en-GB" dirty="0"/>
-              <a:t>Design of Algorithm</a:t>
+              <a:t>Approach and Organisation</a:t>
             </a:r>
           </a:p>
         </p:txBody>
@@ -6325,7 +6443,7 @@
           <p:cNvPr id="3" name="Content Placeholder 2">
             <a:extLst>
               <a:ext uri="{FF2B5EF4-FFF2-40B4-BE49-F238E27FC236}">
-                <a16:creationId xmlns:a16="http://schemas.microsoft.com/office/drawing/2014/main" id="{C0B0A109-1898-6B13-242A-C35CCB8516C1}"/>
+                <a16:creationId xmlns:a16="http://schemas.microsoft.com/office/drawing/2014/main" id="{2FDEE420-E4AD-BB6A-FF3F-3D2C0E975DEA}"/>
               </a:ext>
             </a:extLst>
           </p:cNvPr>
@@ -6341,14 +6459,29 @@
           <a:bodyPr/>
           <a:lstStyle/>
           <a:p>
-            <a:endParaRPr lang="en-GB"/>
+            <a:r>
+              <a:rPr lang="en-GB" dirty="0"/>
+              <a:t>I made use of a new previous GitHub repository I made to store my code as it updated to ensure I have a backup in case anything went wrong.</a:t>
+            </a:r>
+          </a:p>
+          <a:p>
+            <a:r>
+              <a:rPr lang="en-GB" dirty="0"/>
+              <a:t>I also made use of Trello as a checklist of all the features I was currently implementing and to remind myself of the features I have already implemented.</a:t>
+            </a:r>
+          </a:p>
+          <a:p>
+            <a:r>
+              <a:rPr lang="en-GB" dirty="0"/>
+              <a:t>I used a Google Doc to keep track of how I would create my project from the kinds of software I would use to the features I would be interested in coding.</a:t>
+            </a:r>
           </a:p>
         </p:txBody>
       </p:sp>
     </p:spTree>
     <p:extLst>
       <p:ext uri="{BB962C8B-B14F-4D97-AF65-F5344CB8AC3E}">
-        <p14:creationId xmlns:p14="http://schemas.microsoft.com/office/powerpoint/2010/main" val="1223527224"/>
+        <p14:creationId xmlns:p14="http://schemas.microsoft.com/office/powerpoint/2010/main" val="3573069573"/>
       </p:ext>
     </p:extLst>
   </p:cSld>
@@ -6380,7 +6513,7 @@
           <p:cNvPr id="2" name="Title 1">
             <a:extLst>
               <a:ext uri="{FF2B5EF4-FFF2-40B4-BE49-F238E27FC236}">
-                <a16:creationId xmlns:a16="http://schemas.microsoft.com/office/drawing/2014/main" id="{A351A2B6-6A31-D2F6-94D9-A0D190F39CDC}"/>
+                <a16:creationId xmlns:a16="http://schemas.microsoft.com/office/drawing/2014/main" id="{4982E630-CCA6-6F6D-0EE0-9FFB35E1B0AC}"/>
               </a:ext>
             </a:extLst>
           </p:cNvPr>
@@ -6391,14 +6524,19 @@
             <p:ph type="title"/>
           </p:nvPr>
         </p:nvSpPr>
-        <p:spPr/>
+        <p:spPr>
+          <a:xfrm>
+            <a:off x="2611808" y="808056"/>
+            <a:ext cx="4014279" cy="1077229"/>
+          </a:xfrm>
+        </p:spPr>
         <p:txBody>
           <a:bodyPr/>
           <a:lstStyle/>
           <a:p>
             <a:r>
               <a:rPr lang="en-GB" dirty="0"/>
-              <a:t>Message Analysis Algorithm </a:t>
+              <a:t>Design of Algorithm</a:t>
             </a:r>
           </a:p>
         </p:txBody>
@@ -6408,7 +6546,7 @@
           <p:cNvPr id="3" name="Content Placeholder 2">
             <a:extLst>
               <a:ext uri="{FF2B5EF4-FFF2-40B4-BE49-F238E27FC236}">
-                <a16:creationId xmlns:a16="http://schemas.microsoft.com/office/drawing/2014/main" id="{6FFA8C21-AFFD-171A-D1ED-4AD4953BFB8B}"/>
+                <a16:creationId xmlns:a16="http://schemas.microsoft.com/office/drawing/2014/main" id="{C0B0A109-1898-6B13-242A-C35CCB8516C1}"/>
               </a:ext>
             </a:extLst>
           </p:cNvPr>
@@ -6421,17 +6559,46 @@
         </p:nvSpPr>
         <p:spPr/>
         <p:txBody>
-          <a:bodyPr/>
-          <a:lstStyle/>
-          <a:p>
-            <a:endParaRPr lang="en-GB"/>
+          <a:bodyPr>
+            <a:normAutofit lnSpcReduction="10000"/>
+          </a:bodyPr>
+          <a:lstStyle/>
+          <a:p>
+            <a:r>
+              <a:rPr lang="en-GB" dirty="0"/>
+              <a:t>A URL is inputted and multiple heuristic features combined with TF – IDF features are extracted from it, numerical values are returned and a feature vector is formed with them.</a:t>
+            </a:r>
+          </a:p>
+          <a:p>
+            <a:r>
+              <a:rPr lang="en-GB" dirty="0"/>
+              <a:t>A </a:t>
+            </a:r>
+            <a:r>
+              <a:rPr lang="en-GB" dirty="0" err="1"/>
+              <a:t>RandomForestClassifier</a:t>
+            </a:r>
+            <a:r>
+              <a:rPr lang="en-GB" dirty="0"/>
+              <a:t> model is used where 200 decision trees are established to use the feature vector to make a decision on whether the URL is phishing or legit.</a:t>
+            </a:r>
+          </a:p>
+          <a:p>
+            <a:r>
+              <a:rPr lang="en-US" dirty="0"/>
+              <a:t>This hybrid system combining heuristic feature extraction with a machine-learning classifier </a:t>
+            </a:r>
+            <a:r>
+              <a:rPr lang="en-GB" dirty="0"/>
+              <a:t>makes a final decision, the confidence of the AI’s assessment is calculated and is outputted along with the verdict.</a:t>
+            </a:r>
           </a:p>
         </p:txBody>
       </p:sp>
     </p:spTree>
     <p:extLst>
       <p:ext uri="{BB962C8B-B14F-4D97-AF65-F5344CB8AC3E}">
-        <p14:creationId xmlns:p14="http://schemas.microsoft.com/office/powerpoint/2010/main" val="1506504572"/>
+        <p14:creationId xmlns:p14="http://schemas.microsoft.com/office/powerpoint/2010/main" val="1223527224"/>
       </p:ext>
     </p:extLst>
   </p:cSld>
@@ -6509,10 +6676,38 @@
         </p:nvSpPr>
         <p:spPr/>
         <p:txBody>
-          <a:bodyPr/>
-          <a:lstStyle/>
-          <a:p>
-            <a:endParaRPr lang="en-GB"/>
+          <a:bodyPr>
+            <a:normAutofit lnSpcReduction="10000"/>
+          </a:bodyPr>
+          <a:lstStyle/>
+          <a:p>
+            <a:r>
+              <a:rPr lang="en-GB" dirty="0"/>
+              <a:t>All of my code is being programmed in Python with the exception of a few HTML elements related to code for the web interface.</a:t>
+            </a:r>
+          </a:p>
+          <a:p>
+            <a:r>
+              <a:rPr lang="en-GB" dirty="0"/>
+              <a:t>I used Visual Studio Code as my coding environment and </a:t>
+            </a:r>
+            <a:r>
+              <a:rPr lang="en-US" dirty="0"/>
+              <a:t>Anaconda which allowed me to manage my Python environment and dependencies and most importantly reliably run machine-learning libraries like NumPy, Pandas, and scikit-learn without compatibility issues.</a:t>
+            </a:r>
+          </a:p>
+          <a:p>
+            <a:r>
+              <a:rPr lang="en-US" dirty="0"/>
+              <a:t>I also used Flask to build the web interface my project is being ran on.</a:t>
+            </a:r>
+            <a:endParaRPr lang="en-GB" dirty="0"/>
+          </a:p>
+          <a:p>
+            <a:endParaRPr lang="en-GB" dirty="0"/>
+          </a:p>
+          <a:p>
+            <a:endParaRPr lang="en-GB" dirty="0"/>
           </a:p>
         </p:txBody>
       </p:sp>

</xml_diff>